<commit_message>
Update Ain_Token_BI.pptx with new content
</commit_message>
<xml_diff>
--- a/Ain_Token_BI.pptx
+++ b/Ain_Token_BI.pptx
@@ -1288,7 +1288,7 @@
               <a:t>SPEAKER NOTES (~30–40 seconds)
 Ain Token, where Ain means spring or source in Arabic, is a fictional Algerian AI inference provider. It hosts open-source language models on its own GPUs and sells access by the million tokens through an OpenAI-compatible API, with local payment options. The ecosystem includes clients, management, GPU providers, payment partners and support. We analyse performance through four dimensions: client, model, region and time. These become the filters and breakdowns of our dashboard.
 PRESENTER REFERENCE (not spoken)
-Model examples: Qwen3 30B, Qwen3 32B, Coder 32B, Llama 8B. Region examples: Alger, Oran, Constantine, Béjaïa, Batna. Clients: developers, startups, enterprises. Presenter: Kadache Ahmed Rami, 3CS2. Course: Business Intelligence. Ain in Arabic: عين.</a:t>
+Model examples: Qwen3 30B, Qwen3 32B, Coder 32B, Llama 8B. Region examples: Alger, Oran, Constantine, Béjaïa, Batna. Clients: developers, startups, enterprises. Presenters: Kadache Ahmed Rami and Selmani Zakaria, both from 3CS2. Course: Business Intelligence. Ain in Arabic: عين.</a:t>
             </a:r>
             <a:endParaRPr lang="en-US" dirty="0"/>
           </a:p>
@@ -4283,7 +4283,7 @@
                 <a:ea typeface="Calibri" pitchFamily="34" charset="-122"/>
                 <a:cs typeface="Calibri" pitchFamily="34" charset="-120"/>
               </a:rPr>
-              <a:t>Kadache Ahmed Rami  /  3CS2</a:t>
+              <a:t>Kadache Ahmed Rami &amp; Selmani Zakaria  /  3CS2</a:t>
             </a:r>
             <a:endParaRPr lang="en-US" sz="1050" dirty="0"/>
           </a:p>
@@ -6415,7 +6415,7 @@
                 <a:ea typeface="Calibri" pitchFamily="34" charset="-122"/>
                 <a:cs typeface="Calibri" pitchFamily="34" charset="-120"/>
               </a:rPr>
-              <a:t>Kadache Ahmed Rami  /  3CS2</a:t>
+              <a:t>Kadache Ahmed Rami &amp; Selmani Zakaria  /  3CS2</a:t>
             </a:r>
             <a:endParaRPr lang="en-US" sz="1050" dirty="0"/>
           </a:p>
@@ -8622,7 +8622,7 @@
                 <a:ea typeface="Calibri" pitchFamily="34" charset="-122"/>
                 <a:cs typeface="Calibri" pitchFamily="34" charset="-120"/>
               </a:rPr>
-              <a:t>Kadache Ahmed Rami  /  3CS2</a:t>
+              <a:t>Kadache Ahmed Rami &amp; Selmani Zakaria  /  3CS2</a:t>
             </a:r>
             <a:endParaRPr lang="en-US" sz="1050" dirty="0"/>
           </a:p>

</xml_diff>